<commit_message>
Update team credentials, roll numbers, guide (Dr. Nitika Nigam), and department (Information Technology)
</commit_message>
<xml_diff>
--- a/presentation/Minor_Project_Presentation.pptx
+++ b/presentation/Minor_Project_Presentation.pptx
@@ -3413,13 +3413,13 @@
           <a:p>
             <a:pPr algn="ctr"/>
             <a:r>
-              <a:rPr sz="1600" b="1" i="0">
+              <a:rPr sz="1500" b="1" i="0">
                 <a:solidFill>
                   <a:srgbClr val="FFFFFF"/>
                 </a:solidFill>
                 <a:latin typeface="Calibri"/>
               </a:rPr>
-              <a:t>Prince Prajapati (Team Lead)  ·  [Teammate 2]  ·  [Teammate 3]</a:t>
+              <a:t>Prince Prajapati (24124085)  ·  Ayush Bansal (24124025)  ·  Abhay Kaushal (24124003)</a:t>
             </a:r>
           </a:p>
         </p:txBody>
@@ -3454,7 +3454,7 @@
                 </a:solidFill>
                 <a:latin typeface="Calibri"/>
               </a:rPr>
-              <a:t>Department of Computer Science &amp; Engineering  |  Academic Year 2026</a:t>
+              <a:t>Guide: Dr. Nitika Nigam  |  Department of Information Technology  |  Academic Year 2026</a:t>
             </a:r>
           </a:p>
         </p:txBody>
@@ -10084,29 +10084,30 @@
         </p:nvSpPr>
         <p:spPr>
           <a:xfrm>
-            <a:off x="1828800" y="5349240"/>
-            <a:ext cx="8503920" cy="411480"/>
-          </a:xfrm>
-          <a:prstGeom prst="rect">
-            <a:avLst/>
-          </a:prstGeom>
-          <a:noFill/>
-        </p:spPr>
-        <p:txBody>
-          <a:bodyPr wrap="square">
-            <a:spAutoFit/>
-          </a:bodyPr>
-          <a:lstStyle/>
-          <a:p>
-            <a:pPr algn="ctr"/>
-            <a:r>
-              <a:rPr sz="1400" b="0" i="0">
+            <a:off x="1828800" y="5257800"/>
+            <a:ext cx="8503920" cy="548640"/>
+          </a:xfrm>
+          <a:prstGeom prst="rect">
+            <a:avLst/>
+          </a:prstGeom>
+          <a:noFill/>
+        </p:spPr>
+        <p:txBody>
+          <a:bodyPr wrap="square">
+            <a:spAutoFit/>
+          </a:bodyPr>
+          <a:lstStyle/>
+          <a:p>
+            <a:pPr algn="ctr"/>
+            <a:r>
+              <a:rPr sz="1350" b="0" i="0">
                 <a:solidFill>
                   <a:srgbClr val="CCD6E0"/>
                 </a:solidFill>
                 <a:latin typeface="Calibri"/>
               </a:rPr>
-              <a:t>Prince Prajapati  ·  [Teammate 2]  ·  [Teammate 3]</a:t>
+              <a:t>Prince Prajapati (24124085)  ·  Ayush Bansal (24124025)  ·  Abhay Kaushal (24124003)
+Guide: Dr. Nitika Nigam · Department of Information Technology</a:t>
             </a:r>
           </a:p>
         </p:txBody>

</xml_diff>

<commit_message>
Add Dr. Jaspal Kaur Saini alongside Dr. Nitika Nigam as project guides across all materials
</commit_message>
<xml_diff>
--- a/presentation/Minor_Project_Presentation.pptx
+++ b/presentation/Minor_Project_Presentation.pptx
@@ -3454,7 +3454,7 @@
                 </a:solidFill>
                 <a:latin typeface="Calibri"/>
               </a:rPr>
-              <a:t>Guide: Dr. Nitika Nigam  |  Department of Information Technology  |  Academic Year 2026</a:t>
+              <a:t>Guides: Dr. Nitika Nigam  ·  Dr. Jaspal Kaur Saini  |  Department of Information Technology  |  Academic Year 2026</a:t>
             </a:r>
           </a:p>
         </p:txBody>
@@ -10107,7 +10107,7 @@
                 <a:latin typeface="Calibri"/>
               </a:rPr>
               <a:t>Prince Prajapati (24124085)  ·  Ayush Bansal (24124025)  ·  Abhay Kaushal (24124003)
-Guide: Dr. Nitika Nigam · Department of Information Technology</a:t>
+Guides: Dr. Nitika Nigam  ·  Dr. Jaspal Kaur Saini  ·  Department of Information Technology</a:t>
             </a:r>
           </a:p>
         </p:txBody>

</xml_diff>